<commit_message>
demo fills are added for registration, travel insu
</commit_message>
<xml_diff>
--- a/docs/Reboot-2026-Platform-Overview.pptx
+++ b/docs/Reboot-2026-Platform-Overview.pptx
@@ -5,31 +5,31 @@
     <p:sldMasterId id="2147483648" r:id="rId1"/>
   </p:sldMasterIdLst>
   <p:sldIdLst>
-    <p:sldId id="256" r:id="rId7"/>
-    <p:sldId id="257" r:id="rId8"/>
-    <p:sldId id="258" r:id="rId9"/>
-    <p:sldId id="259" r:id="rId10"/>
-    <p:sldId id="260" r:id="rId11"/>
-    <p:sldId id="261" r:id="rId12"/>
-    <p:sldId id="262" r:id="rId13"/>
-    <p:sldId id="263" r:id="rId14"/>
-    <p:sldId id="264" r:id="rId15"/>
-    <p:sldId id="265" r:id="rId16"/>
-    <p:sldId id="266" r:id="rId17"/>
-    <p:sldId id="267" r:id="rId18"/>
-    <p:sldId id="268" r:id="rId19"/>
-    <p:sldId id="269" r:id="rId20"/>
-    <p:sldId id="270" r:id="rId21"/>
-    <p:sldId id="271" r:id="rId22"/>
-    <p:sldId id="272" r:id="rId23"/>
-    <p:sldId id="273" r:id="rId24"/>
-    <p:sldId id="274" r:id="rId25"/>
-    <p:sldId id="275" r:id="rId26"/>
-    <p:sldId id="276" r:id="rId27"/>
-    <p:sldId id="277" r:id="rId28"/>
-    <p:sldId id="278" r:id="rId29"/>
+    <p:sldId id="256" r:id="rId2"/>
+    <p:sldId id="257" r:id="rId3"/>
+    <p:sldId id="258" r:id="rId4"/>
+    <p:sldId id="259" r:id="rId5"/>
+    <p:sldId id="260" r:id="rId6"/>
+    <p:sldId id="261" r:id="rId7"/>
+    <p:sldId id="262" r:id="rId8"/>
+    <p:sldId id="263" r:id="rId9"/>
+    <p:sldId id="264" r:id="rId10"/>
+    <p:sldId id="265" r:id="rId11"/>
+    <p:sldId id="266" r:id="rId12"/>
+    <p:sldId id="267" r:id="rId13"/>
+    <p:sldId id="268" r:id="rId14"/>
+    <p:sldId id="269" r:id="rId15"/>
+    <p:sldId id="270" r:id="rId16"/>
+    <p:sldId id="271" r:id="rId17"/>
+    <p:sldId id="272" r:id="rId18"/>
+    <p:sldId id="273" r:id="rId19"/>
+    <p:sldId id="274" r:id="rId20"/>
+    <p:sldId id="275" r:id="rId21"/>
+    <p:sldId id="276" r:id="rId22"/>
+    <p:sldId id="277" r:id="rId23"/>
+    <p:sldId id="278" r:id="rId24"/>
   </p:sldIdLst>
-  <p:sldSz cx="12191695" cy="6858000" type="screen4x3"/>
+  <p:sldSz cx="12192000" cy="6858000"/>
   <p:notesSz cx="6858000" cy="9144000"/>
   <p:defaultTextStyle>
     <a:defPPr>
@@ -126,6 +126,22 @@
       </a:defRPr>
     </a:lvl9pPr>
   </p:defaultTextStyle>
+  <p:extLst>
+    <p:ext uri="{EFAFB233-063F-42B5-8137-9DF3F51BA10A}">
+      <p15:sldGuideLst xmlns:p15="http://schemas.microsoft.com/office/powerpoint/2012/main">
+        <p15:guide id="1" orient="horz" pos="2160">
+          <p15:clr>
+            <a:srgbClr val="A4A3A4"/>
+          </p15:clr>
+        </p15:guide>
+        <p15:guide id="2" pos="2880">
+          <p15:clr>
+            <a:srgbClr val="A4A3A4"/>
+          </p15:clr>
+        </p15:guide>
+      </p15:sldGuideLst>
+    </p:ext>
+  </p:extLst>
 </p:presentation>
 </file>
 
@@ -167,10 +183,9 @@
           <a:lstStyle/>
           <a:p>
             <a:r>
-              <a:rPr lang="en-US" smtClean="0"/>
+              <a:rPr lang="en-US"/>
               <a:t>Click to edit Master title style</a:t>
             </a:r>
-            <a:endParaRPr lang="en-US"/>
           </a:p>
         </p:txBody>
       </p:sp>
@@ -286,10 +301,9 @@
           </a:lstStyle>
           <a:p>
             <a:r>
-              <a:rPr lang="en-US" smtClean="0"/>
+              <a:rPr lang="en-US"/>
               <a:t>Click to edit Master subtitle style</a:t>
             </a:r>
-            <a:endParaRPr lang="en-US"/>
           </a:p>
         </p:txBody>
       </p:sp>
@@ -310,7 +324,7 @@
           <a:p>
             <a:fld id="{5BCAD085-E8A6-8845-BD4E-CB4CCA059FC4}" type="datetimeFigureOut">
               <a:rPr lang="en-US" smtClean="0"/>
-              <a:t>1/27/13</a:t>
+              <a:t>7/30/2026</a:t>
             </a:fld>
             <a:endParaRPr lang="en-US"/>
           </a:p>
@@ -404,10 +418,9 @@
           <a:lstStyle/>
           <a:p>
             <a:r>
-              <a:rPr lang="en-US" smtClean="0"/>
+              <a:rPr lang="en-US"/>
               <a:t>Click to edit Master title style</a:t>
             </a:r>
-            <a:endParaRPr lang="en-US"/>
           </a:p>
         </p:txBody>
       </p:sp>
@@ -428,38 +441,37 @@
           <a:p>
             <a:pPr lvl="0"/>
             <a:r>
-              <a:rPr lang="en-US" smtClean="0"/>
+              <a:rPr lang="en-US"/>
               <a:t>Click to edit Master text styles</a:t>
             </a:r>
           </a:p>
           <a:p>
             <a:pPr lvl="1"/>
             <a:r>
-              <a:rPr lang="en-US" smtClean="0"/>
+              <a:rPr lang="en-US"/>
               <a:t>Second level</a:t>
             </a:r>
           </a:p>
           <a:p>
             <a:pPr lvl="2"/>
             <a:r>
-              <a:rPr lang="en-US" smtClean="0"/>
+              <a:rPr lang="en-US"/>
               <a:t>Third level</a:t>
             </a:r>
           </a:p>
           <a:p>
             <a:pPr lvl="3"/>
             <a:r>
-              <a:rPr lang="en-US" smtClean="0"/>
+              <a:rPr lang="en-US"/>
               <a:t>Fourth level</a:t>
             </a:r>
           </a:p>
           <a:p>
             <a:pPr lvl="4"/>
             <a:r>
-              <a:rPr lang="en-US" smtClean="0"/>
+              <a:rPr lang="en-US"/>
               <a:t>Fifth level</a:t>
             </a:r>
-            <a:endParaRPr lang="en-US"/>
           </a:p>
         </p:txBody>
       </p:sp>
@@ -480,7 +492,7 @@
           <a:p>
             <a:fld id="{5BCAD085-E8A6-8845-BD4E-CB4CCA059FC4}" type="datetimeFigureOut">
               <a:rPr lang="en-US" smtClean="0"/>
-              <a:t>1/27/13</a:t>
+              <a:t>7/30/2026</a:t>
             </a:fld>
             <a:endParaRPr lang="en-US"/>
           </a:p>
@@ -579,10 +591,9 @@
           <a:lstStyle/>
           <a:p>
             <a:r>
-              <a:rPr lang="en-US" smtClean="0"/>
+              <a:rPr lang="en-US"/>
               <a:t>Click to edit Master title style</a:t>
             </a:r>
-            <a:endParaRPr lang="en-US"/>
           </a:p>
         </p:txBody>
       </p:sp>
@@ -608,38 +619,37 @@
           <a:p>
             <a:pPr lvl="0"/>
             <a:r>
-              <a:rPr lang="en-US" smtClean="0"/>
+              <a:rPr lang="en-US"/>
               <a:t>Click to edit Master text styles</a:t>
             </a:r>
           </a:p>
           <a:p>
             <a:pPr lvl="1"/>
             <a:r>
-              <a:rPr lang="en-US" smtClean="0"/>
+              <a:rPr lang="en-US"/>
               <a:t>Second level</a:t>
             </a:r>
           </a:p>
           <a:p>
             <a:pPr lvl="2"/>
             <a:r>
-              <a:rPr lang="en-US" smtClean="0"/>
+              <a:rPr lang="en-US"/>
               <a:t>Third level</a:t>
             </a:r>
           </a:p>
           <a:p>
             <a:pPr lvl="3"/>
             <a:r>
-              <a:rPr lang="en-US" smtClean="0"/>
+              <a:rPr lang="en-US"/>
               <a:t>Fourth level</a:t>
             </a:r>
           </a:p>
           <a:p>
             <a:pPr lvl="4"/>
             <a:r>
-              <a:rPr lang="en-US" smtClean="0"/>
+              <a:rPr lang="en-US"/>
               <a:t>Fifth level</a:t>
             </a:r>
-            <a:endParaRPr lang="en-US"/>
           </a:p>
         </p:txBody>
       </p:sp>
@@ -660,7 +670,7 @@
           <a:p>
             <a:fld id="{5BCAD085-E8A6-8845-BD4E-CB4CCA059FC4}" type="datetimeFigureOut">
               <a:rPr lang="en-US" smtClean="0"/>
-              <a:t>1/27/13</a:t>
+              <a:t>7/30/2026</a:t>
             </a:fld>
             <a:endParaRPr lang="en-US"/>
           </a:p>
@@ -754,10 +764,9 @@
           <a:lstStyle/>
           <a:p>
             <a:r>
-              <a:rPr lang="en-US" smtClean="0"/>
+              <a:rPr lang="en-US"/>
               <a:t>Click to edit Master title style</a:t>
             </a:r>
-            <a:endParaRPr lang="en-US"/>
           </a:p>
         </p:txBody>
       </p:sp>
@@ -778,38 +787,37 @@
           <a:p>
             <a:pPr lvl="0"/>
             <a:r>
-              <a:rPr lang="en-US" smtClean="0"/>
+              <a:rPr lang="en-US"/>
               <a:t>Click to edit Master text styles</a:t>
             </a:r>
           </a:p>
           <a:p>
             <a:pPr lvl="1"/>
             <a:r>
-              <a:rPr lang="en-US" smtClean="0"/>
+              <a:rPr lang="en-US"/>
               <a:t>Second level</a:t>
             </a:r>
           </a:p>
           <a:p>
             <a:pPr lvl="2"/>
             <a:r>
-              <a:rPr lang="en-US" smtClean="0"/>
+              <a:rPr lang="en-US"/>
               <a:t>Third level</a:t>
             </a:r>
           </a:p>
           <a:p>
             <a:pPr lvl="3"/>
             <a:r>
-              <a:rPr lang="en-US" smtClean="0"/>
+              <a:rPr lang="en-US"/>
               <a:t>Fourth level</a:t>
             </a:r>
           </a:p>
           <a:p>
             <a:pPr lvl="4"/>
             <a:r>
-              <a:rPr lang="en-US" smtClean="0"/>
+              <a:rPr lang="en-US"/>
               <a:t>Fifth level</a:t>
             </a:r>
-            <a:endParaRPr lang="en-US"/>
           </a:p>
         </p:txBody>
       </p:sp>
@@ -830,7 +838,7 @@
           <a:p>
             <a:fld id="{5BCAD085-E8A6-8845-BD4E-CB4CCA059FC4}" type="datetimeFigureOut">
               <a:rPr lang="en-US" smtClean="0"/>
-              <a:t>1/27/13</a:t>
+              <a:t>7/30/2026</a:t>
             </a:fld>
             <a:endParaRPr lang="en-US"/>
           </a:p>
@@ -933,10 +941,9 @@
           </a:lstStyle>
           <a:p>
             <a:r>
-              <a:rPr lang="en-US" smtClean="0"/>
+              <a:rPr lang="en-US"/>
               <a:t>Click to edit Master title style</a:t>
             </a:r>
-            <a:endParaRPr lang="en-US"/>
           </a:p>
         </p:txBody>
       </p:sp>
@@ -1053,7 +1060,7 @@
           <a:p>
             <a:pPr lvl="0"/>
             <a:r>
-              <a:rPr lang="en-US" smtClean="0"/>
+              <a:rPr lang="en-US"/>
               <a:t>Click to edit Master text styles</a:t>
             </a:r>
           </a:p>
@@ -1076,7 +1083,7 @@
           <a:p>
             <a:fld id="{5BCAD085-E8A6-8845-BD4E-CB4CCA059FC4}" type="datetimeFigureOut">
               <a:rPr lang="en-US" smtClean="0"/>
-              <a:t>1/27/13</a:t>
+              <a:t>7/30/2026</a:t>
             </a:fld>
             <a:endParaRPr lang="en-US"/>
           </a:p>
@@ -1170,10 +1177,9 @@
           <a:lstStyle/>
           <a:p>
             <a:r>
-              <a:rPr lang="en-US" smtClean="0"/>
+              <a:rPr lang="en-US"/>
               <a:t>Click to edit Master title style</a:t>
             </a:r>
-            <a:endParaRPr lang="en-US"/>
           </a:p>
         </p:txBody>
       </p:sp>
@@ -1227,38 +1233,37 @@
           <a:p>
             <a:pPr lvl="0"/>
             <a:r>
-              <a:rPr lang="en-US" smtClean="0"/>
+              <a:rPr lang="en-US"/>
               <a:t>Click to edit Master text styles</a:t>
             </a:r>
           </a:p>
           <a:p>
             <a:pPr lvl="1"/>
             <a:r>
-              <a:rPr lang="en-US" smtClean="0"/>
+              <a:rPr lang="en-US"/>
               <a:t>Second level</a:t>
             </a:r>
           </a:p>
           <a:p>
             <a:pPr lvl="2"/>
             <a:r>
-              <a:rPr lang="en-US" smtClean="0"/>
+              <a:rPr lang="en-US"/>
               <a:t>Third level</a:t>
             </a:r>
           </a:p>
           <a:p>
             <a:pPr lvl="3"/>
             <a:r>
-              <a:rPr lang="en-US" smtClean="0"/>
+              <a:rPr lang="en-US"/>
               <a:t>Fourth level</a:t>
             </a:r>
           </a:p>
           <a:p>
             <a:pPr lvl="4"/>
             <a:r>
-              <a:rPr lang="en-US" smtClean="0"/>
+              <a:rPr lang="en-US"/>
               <a:t>Fifth level</a:t>
             </a:r>
-            <a:endParaRPr lang="en-US"/>
           </a:p>
         </p:txBody>
       </p:sp>
@@ -1312,38 +1317,37 @@
           <a:p>
             <a:pPr lvl="0"/>
             <a:r>
-              <a:rPr lang="en-US" smtClean="0"/>
+              <a:rPr lang="en-US"/>
               <a:t>Click to edit Master text styles</a:t>
             </a:r>
           </a:p>
           <a:p>
             <a:pPr lvl="1"/>
             <a:r>
-              <a:rPr lang="en-US" smtClean="0"/>
+              <a:rPr lang="en-US"/>
               <a:t>Second level</a:t>
             </a:r>
           </a:p>
           <a:p>
             <a:pPr lvl="2"/>
             <a:r>
-              <a:rPr lang="en-US" smtClean="0"/>
+              <a:rPr lang="en-US"/>
               <a:t>Third level</a:t>
             </a:r>
           </a:p>
           <a:p>
             <a:pPr lvl="3"/>
             <a:r>
-              <a:rPr lang="en-US" smtClean="0"/>
+              <a:rPr lang="en-US"/>
               <a:t>Fourth level</a:t>
             </a:r>
           </a:p>
           <a:p>
             <a:pPr lvl="4"/>
             <a:r>
-              <a:rPr lang="en-US" smtClean="0"/>
+              <a:rPr lang="en-US"/>
               <a:t>Fifth level</a:t>
             </a:r>
-            <a:endParaRPr lang="en-US"/>
           </a:p>
         </p:txBody>
       </p:sp>
@@ -1364,7 +1368,7 @@
           <a:p>
             <a:fld id="{5BCAD085-E8A6-8845-BD4E-CB4CCA059FC4}" type="datetimeFigureOut">
               <a:rPr lang="en-US" smtClean="0"/>
-              <a:t>1/27/13</a:t>
+              <a:t>7/30/2026</a:t>
             </a:fld>
             <a:endParaRPr lang="en-US"/>
           </a:p>
@@ -1462,10 +1466,9 @@
           </a:lstStyle>
           <a:p>
             <a:r>
-              <a:rPr lang="en-US" smtClean="0"/>
+              <a:rPr lang="en-US"/>
               <a:t>Click to edit Master title style</a:t>
             </a:r>
-            <a:endParaRPr lang="en-US"/>
           </a:p>
         </p:txBody>
       </p:sp>
@@ -1528,7 +1531,7 @@
           <a:p>
             <a:pPr lvl="0"/>
             <a:r>
-              <a:rPr lang="en-US" smtClean="0"/>
+              <a:rPr lang="en-US"/>
               <a:t>Click to edit Master text styles</a:t>
             </a:r>
           </a:p>
@@ -1584,38 +1587,37 @@
           <a:p>
             <a:pPr lvl="0"/>
             <a:r>
-              <a:rPr lang="en-US" smtClean="0"/>
+              <a:rPr lang="en-US"/>
               <a:t>Click to edit Master text styles</a:t>
             </a:r>
           </a:p>
           <a:p>
             <a:pPr lvl="1"/>
             <a:r>
-              <a:rPr lang="en-US" smtClean="0"/>
+              <a:rPr lang="en-US"/>
               <a:t>Second level</a:t>
             </a:r>
           </a:p>
           <a:p>
             <a:pPr lvl="2"/>
             <a:r>
-              <a:rPr lang="en-US" smtClean="0"/>
+              <a:rPr lang="en-US"/>
               <a:t>Third level</a:t>
             </a:r>
           </a:p>
           <a:p>
             <a:pPr lvl="3"/>
             <a:r>
-              <a:rPr lang="en-US" smtClean="0"/>
+              <a:rPr lang="en-US"/>
               <a:t>Fourth level</a:t>
             </a:r>
           </a:p>
           <a:p>
             <a:pPr lvl="4"/>
             <a:r>
-              <a:rPr lang="en-US" smtClean="0"/>
+              <a:rPr lang="en-US"/>
               <a:t>Fifth level</a:t>
             </a:r>
-            <a:endParaRPr lang="en-US"/>
           </a:p>
         </p:txBody>
       </p:sp>
@@ -1678,7 +1680,7 @@
           <a:p>
             <a:pPr lvl="0"/>
             <a:r>
-              <a:rPr lang="en-US" smtClean="0"/>
+              <a:rPr lang="en-US"/>
               <a:t>Click to edit Master text styles</a:t>
             </a:r>
           </a:p>
@@ -1734,38 +1736,37 @@
           <a:p>
             <a:pPr lvl="0"/>
             <a:r>
-              <a:rPr lang="en-US" smtClean="0"/>
+              <a:rPr lang="en-US"/>
               <a:t>Click to edit Master text styles</a:t>
             </a:r>
           </a:p>
           <a:p>
             <a:pPr lvl="1"/>
             <a:r>
-              <a:rPr lang="en-US" smtClean="0"/>
+              <a:rPr lang="en-US"/>
               <a:t>Second level</a:t>
             </a:r>
           </a:p>
           <a:p>
             <a:pPr lvl="2"/>
             <a:r>
-              <a:rPr lang="en-US" smtClean="0"/>
+              <a:rPr lang="en-US"/>
               <a:t>Third level</a:t>
             </a:r>
           </a:p>
           <a:p>
             <a:pPr lvl="3"/>
             <a:r>
-              <a:rPr lang="en-US" smtClean="0"/>
+              <a:rPr lang="en-US"/>
               <a:t>Fourth level</a:t>
             </a:r>
           </a:p>
           <a:p>
             <a:pPr lvl="4"/>
             <a:r>
-              <a:rPr lang="en-US" smtClean="0"/>
+              <a:rPr lang="en-US"/>
               <a:t>Fifth level</a:t>
             </a:r>
-            <a:endParaRPr lang="en-US"/>
           </a:p>
         </p:txBody>
       </p:sp>
@@ -1786,7 +1787,7 @@
           <a:p>
             <a:fld id="{5BCAD085-E8A6-8845-BD4E-CB4CCA059FC4}" type="datetimeFigureOut">
               <a:rPr lang="en-US" smtClean="0"/>
-              <a:t>1/27/13</a:t>
+              <a:t>7/30/2026</a:t>
             </a:fld>
             <a:endParaRPr lang="en-US"/>
           </a:p>
@@ -1880,10 +1881,9 @@
           <a:lstStyle/>
           <a:p>
             <a:r>
-              <a:rPr lang="en-US" smtClean="0"/>
+              <a:rPr lang="en-US"/>
               <a:t>Click to edit Master title style</a:t>
             </a:r>
-            <a:endParaRPr lang="en-US"/>
           </a:p>
         </p:txBody>
       </p:sp>
@@ -1904,7 +1904,7 @@
           <a:p>
             <a:fld id="{5BCAD085-E8A6-8845-BD4E-CB4CCA059FC4}" type="datetimeFigureOut">
               <a:rPr lang="en-US" smtClean="0"/>
-              <a:t>1/27/13</a:t>
+              <a:t>7/30/2026</a:t>
             </a:fld>
             <a:endParaRPr lang="en-US"/>
           </a:p>
@@ -1999,7 +1999,7 @@
           <a:p>
             <a:fld id="{5BCAD085-E8A6-8845-BD4E-CB4CCA059FC4}" type="datetimeFigureOut">
               <a:rPr lang="en-US" smtClean="0"/>
-              <a:t>1/27/13</a:t>
+              <a:t>7/30/2026</a:t>
             </a:fld>
             <a:endParaRPr lang="en-US"/>
           </a:p>
@@ -2102,10 +2102,9 @@
           </a:lstStyle>
           <a:p>
             <a:r>
-              <a:rPr lang="en-US" smtClean="0"/>
+              <a:rPr lang="en-US"/>
               <a:t>Click to edit Master title style</a:t>
             </a:r>
-            <a:endParaRPr lang="en-US"/>
           </a:p>
         </p:txBody>
       </p:sp>
@@ -2159,38 +2158,37 @@
           <a:p>
             <a:pPr lvl="0"/>
             <a:r>
-              <a:rPr lang="en-US" smtClean="0"/>
+              <a:rPr lang="en-US"/>
               <a:t>Click to edit Master text styles</a:t>
             </a:r>
           </a:p>
           <a:p>
             <a:pPr lvl="1"/>
             <a:r>
-              <a:rPr lang="en-US" smtClean="0"/>
+              <a:rPr lang="en-US"/>
               <a:t>Second level</a:t>
             </a:r>
           </a:p>
           <a:p>
             <a:pPr lvl="2"/>
             <a:r>
-              <a:rPr lang="en-US" smtClean="0"/>
+              <a:rPr lang="en-US"/>
               <a:t>Third level</a:t>
             </a:r>
           </a:p>
           <a:p>
             <a:pPr lvl="3"/>
             <a:r>
-              <a:rPr lang="en-US" smtClean="0"/>
+              <a:rPr lang="en-US"/>
               <a:t>Fourth level</a:t>
             </a:r>
           </a:p>
           <a:p>
             <a:pPr lvl="4"/>
             <a:r>
-              <a:rPr lang="en-US" smtClean="0"/>
+              <a:rPr lang="en-US"/>
               <a:t>Fifth level</a:t>
             </a:r>
-            <a:endParaRPr lang="en-US"/>
           </a:p>
         </p:txBody>
       </p:sp>
@@ -2253,7 +2251,7 @@
           <a:p>
             <a:pPr lvl="0"/>
             <a:r>
-              <a:rPr lang="en-US" smtClean="0"/>
+              <a:rPr lang="en-US"/>
               <a:t>Click to edit Master text styles</a:t>
             </a:r>
           </a:p>
@@ -2276,7 +2274,7 @@
           <a:p>
             <a:fld id="{5BCAD085-E8A6-8845-BD4E-CB4CCA059FC4}" type="datetimeFigureOut">
               <a:rPr lang="en-US" smtClean="0"/>
-              <a:t>1/27/13</a:t>
+              <a:t>7/30/2026</a:t>
             </a:fld>
             <a:endParaRPr lang="en-US"/>
           </a:p>
@@ -2379,10 +2377,9 @@
           </a:lstStyle>
           <a:p>
             <a:r>
-              <a:rPr lang="en-US" smtClean="0"/>
+              <a:rPr lang="en-US"/>
               <a:t>Click to edit Master title style</a:t>
             </a:r>
-            <a:endParaRPr lang="en-US"/>
           </a:p>
         </p:txBody>
       </p:sp>
@@ -2506,7 +2503,7 @@
           <a:p>
             <a:pPr lvl="0"/>
             <a:r>
-              <a:rPr lang="en-US" smtClean="0"/>
+              <a:rPr lang="en-US"/>
               <a:t>Click to edit Master text styles</a:t>
             </a:r>
           </a:p>
@@ -2529,7 +2526,7 @@
           <a:p>
             <a:fld id="{5BCAD085-E8A6-8845-BD4E-CB4CCA059FC4}" type="datetimeFigureOut">
               <a:rPr lang="en-US" smtClean="0"/>
-              <a:t>1/27/13</a:t>
+              <a:t>7/30/2026</a:t>
             </a:fld>
             <a:endParaRPr lang="en-US"/>
           </a:p>
@@ -2638,10 +2635,9 @@
           <a:lstStyle/>
           <a:p>
             <a:r>
-              <a:rPr lang="en-US" smtClean="0"/>
+              <a:rPr lang="en-US"/>
               <a:t>Click to edit Master title style</a:t>
             </a:r>
-            <a:endParaRPr lang="en-US"/>
           </a:p>
         </p:txBody>
       </p:sp>
@@ -2672,38 +2668,37 @@
           <a:p>
             <a:pPr lvl="0"/>
             <a:r>
-              <a:rPr lang="en-US" smtClean="0"/>
+              <a:rPr lang="en-US"/>
               <a:t>Click to edit Master text styles</a:t>
             </a:r>
           </a:p>
           <a:p>
             <a:pPr lvl="1"/>
             <a:r>
-              <a:rPr lang="en-US" smtClean="0"/>
+              <a:rPr lang="en-US"/>
               <a:t>Second level</a:t>
             </a:r>
           </a:p>
           <a:p>
             <a:pPr lvl="2"/>
             <a:r>
-              <a:rPr lang="en-US" smtClean="0"/>
+              <a:rPr lang="en-US"/>
               <a:t>Third level</a:t>
             </a:r>
           </a:p>
           <a:p>
             <a:pPr lvl="3"/>
             <a:r>
-              <a:rPr lang="en-US" smtClean="0"/>
+              <a:rPr lang="en-US"/>
               <a:t>Fourth level</a:t>
             </a:r>
           </a:p>
           <a:p>
             <a:pPr lvl="4"/>
             <a:r>
-              <a:rPr lang="en-US" smtClean="0"/>
+              <a:rPr lang="en-US"/>
               <a:t>Fifth level</a:t>
             </a:r>
-            <a:endParaRPr lang="en-US"/>
           </a:p>
         </p:txBody>
       </p:sp>
@@ -2742,7 +2737,7 @@
           <a:p>
             <a:fld id="{5BCAD085-E8A6-8845-BD4E-CB4CCA059FC4}" type="datetimeFigureOut">
               <a:rPr lang="en-US" smtClean="0"/>
-              <a:t>1/27/13</a:t>
+              <a:t>7/30/2026</a:t>
             </a:fld>
             <a:endParaRPr lang="en-US"/>
           </a:p>
@@ -3101,7 +3096,7 @@
 </file>
 
 <file path=ppt/slides/slide1.xml><?xml version="1.0" encoding="utf-8"?>
-<p:sld xmlns:a="http://schemas.openxmlformats.org/drawingml/2006/main" xmlns:p="http://schemas.openxmlformats.org/presentationml/2006/main" xmlns:r="http://schemas.openxmlformats.org/officeDocument/2006/relationships">
+<p:sld xmlns:a="http://schemas.openxmlformats.org/drawingml/2006/main" xmlns:r="http://schemas.openxmlformats.org/officeDocument/2006/relationships" xmlns:p="http://schemas.openxmlformats.org/presentationml/2006/main">
   <p:cSld>
     <p:bg>
       <p:bgPr>
@@ -3117,7 +3112,14 @@
         <p:cNvGrpSpPr/>
         <p:nvPr/>
       </p:nvGrpSpPr>
-      <p:grpSpPr/>
+      <p:grpSpPr>
+        <a:xfrm>
+          <a:off x="0" y="0"/>
+          <a:ext cx="0" cy="0"/>
+          <a:chOff x="0" y="0"/>
+          <a:chExt cx="0" cy="0"/>
+        </a:xfrm>
+      </p:grpSpPr>
       <p:sp>
         <p:nvSpPr>
           <p:cNvPr id="2" name="Rectangle 1"/>
@@ -3158,6 +3160,7 @@
           <a:lstStyle/>
           <a:p>
             <a:pPr algn="ctr"/>
+            <a:endParaRPr/>
           </a:p>
         </p:txBody>
       </p:sp>
@@ -3170,7 +3173,7 @@
         <p:spPr>
           <a:xfrm>
             <a:off x="685800" y="2011680"/>
-            <a:ext cx="10515600" cy="1371600"/>
+            <a:ext cx="6626429" cy="707886"/>
           </a:xfrm>
           <a:prstGeom prst="rect">
             <a:avLst/>
@@ -3191,7 +3194,12 @@
               </a:defRPr>
             </a:pPr>
             <a:r>
-              <a:t>Reboot 2026 Insurance Platform</a:t>
+              <a:rPr lang="en-IN" dirty="0"/>
+              <a:t>Insurer360 </a:t>
+            </a:r>
+            <a:r>
+              <a:rPr dirty="0"/>
+              <a:t>Insurance Platform</a:t>
             </a:r>
           </a:p>
         </p:txBody>
@@ -3275,7 +3283,7 @@
 </file>
 
 <file path=ppt/slides/slide10.xml><?xml version="1.0" encoding="utf-8"?>
-<p:sld xmlns:a="http://schemas.openxmlformats.org/drawingml/2006/main" xmlns:p="http://schemas.openxmlformats.org/presentationml/2006/main" xmlns:r="http://schemas.openxmlformats.org/officeDocument/2006/relationships">
+<p:sld xmlns:a="http://schemas.openxmlformats.org/drawingml/2006/main" xmlns:r="http://schemas.openxmlformats.org/officeDocument/2006/relationships" xmlns:p="http://schemas.openxmlformats.org/presentationml/2006/main">
   <p:cSld>
     <p:bg>
       <p:bgPr>
@@ -3291,7 +3299,14 @@
         <p:cNvGrpSpPr/>
         <p:nvPr/>
       </p:nvGrpSpPr>
-      <p:grpSpPr/>
+      <p:grpSpPr>
+        <a:xfrm>
+          <a:off x="0" y="0"/>
+          <a:ext cx="0" cy="0"/>
+          <a:chOff x="0" y="0"/>
+          <a:chExt cx="0" cy="0"/>
+        </a:xfrm>
+      </p:grpSpPr>
       <p:sp>
         <p:nvSpPr>
           <p:cNvPr id="2" name="TextBox 1"/>
@@ -3371,7 +3386,7 @@
 </file>
 
 <file path=ppt/slides/slide11.xml><?xml version="1.0" encoding="utf-8"?>
-<p:sld xmlns:a="http://schemas.openxmlformats.org/drawingml/2006/main" xmlns:p="http://schemas.openxmlformats.org/presentationml/2006/main" xmlns:r="http://schemas.openxmlformats.org/officeDocument/2006/relationships">
+<p:sld xmlns:a="http://schemas.openxmlformats.org/drawingml/2006/main" xmlns:r="http://schemas.openxmlformats.org/officeDocument/2006/relationships" xmlns:p="http://schemas.openxmlformats.org/presentationml/2006/main">
   <p:cSld>
     <p:bg>
       <p:bgPr>
@@ -3387,7 +3402,14 @@
         <p:cNvGrpSpPr/>
         <p:nvPr/>
       </p:nvGrpSpPr>
-      <p:grpSpPr/>
+      <p:grpSpPr>
+        <a:xfrm>
+          <a:off x="0" y="0"/>
+          <a:ext cx="0" cy="0"/>
+          <a:chOff x="0" y="0"/>
+          <a:chExt cx="0" cy="0"/>
+        </a:xfrm>
+      </p:grpSpPr>
       <p:sp>
         <p:nvSpPr>
           <p:cNvPr id="2" name="Rectangle 1"/>
@@ -3428,6 +3450,7 @@
           <a:lstStyle/>
           <a:p>
             <a:pPr algn="ctr"/>
+            <a:endParaRPr/>
           </a:p>
         </p:txBody>
       </p:sp>
@@ -3623,7 +3646,7 @@
 </file>
 
 <file path=ppt/slides/slide12.xml><?xml version="1.0" encoding="utf-8"?>
-<p:sld xmlns:a="http://schemas.openxmlformats.org/drawingml/2006/main" xmlns:p="http://schemas.openxmlformats.org/presentationml/2006/main" xmlns:r="http://schemas.openxmlformats.org/officeDocument/2006/relationships">
+<p:sld xmlns:a="http://schemas.openxmlformats.org/drawingml/2006/main" xmlns:r="http://schemas.openxmlformats.org/officeDocument/2006/relationships" xmlns:p="http://schemas.openxmlformats.org/presentationml/2006/main">
   <p:cSld>
     <p:bg>
       <p:bgPr>
@@ -3639,7 +3662,14 @@
         <p:cNvGrpSpPr/>
         <p:nvPr/>
       </p:nvGrpSpPr>
-      <p:grpSpPr/>
+      <p:grpSpPr>
+        <a:xfrm>
+          <a:off x="0" y="0"/>
+          <a:ext cx="0" cy="0"/>
+          <a:chOff x="0" y="0"/>
+          <a:chExt cx="0" cy="0"/>
+        </a:xfrm>
+      </p:grpSpPr>
       <p:sp>
         <p:nvSpPr>
           <p:cNvPr id="2" name="Rectangle 1"/>
@@ -3680,6 +3710,7 @@
           <a:lstStyle/>
           <a:p>
             <a:pPr algn="ctr"/>
+            <a:endParaRPr/>
           </a:p>
         </p:txBody>
       </p:sp>
@@ -3875,7 +3906,7 @@
 </file>
 
 <file path=ppt/slides/slide13.xml><?xml version="1.0" encoding="utf-8"?>
-<p:sld xmlns:a="http://schemas.openxmlformats.org/drawingml/2006/main" xmlns:p="http://schemas.openxmlformats.org/presentationml/2006/main" xmlns:r="http://schemas.openxmlformats.org/officeDocument/2006/relationships">
+<p:sld xmlns:a="http://schemas.openxmlformats.org/drawingml/2006/main" xmlns:r="http://schemas.openxmlformats.org/officeDocument/2006/relationships" xmlns:p="http://schemas.openxmlformats.org/presentationml/2006/main">
   <p:cSld>
     <p:bg>
       <p:bgPr>
@@ -3891,7 +3922,14 @@
         <p:cNvGrpSpPr/>
         <p:nvPr/>
       </p:nvGrpSpPr>
-      <p:grpSpPr/>
+      <p:grpSpPr>
+        <a:xfrm>
+          <a:off x="0" y="0"/>
+          <a:ext cx="0" cy="0"/>
+          <a:chOff x="0" y="0"/>
+          <a:chExt cx="0" cy="0"/>
+        </a:xfrm>
+      </p:grpSpPr>
       <p:sp>
         <p:nvSpPr>
           <p:cNvPr id="2" name="Rectangle 1"/>
@@ -3932,6 +3970,7 @@
           <a:lstStyle/>
           <a:p>
             <a:pPr algn="ctr"/>
+            <a:endParaRPr/>
           </a:p>
         </p:txBody>
       </p:sp>
@@ -4192,7 +4231,7 @@
 </file>
 
 <file path=ppt/slides/slide14.xml><?xml version="1.0" encoding="utf-8"?>
-<p:sld xmlns:a="http://schemas.openxmlformats.org/drawingml/2006/main" xmlns:p="http://schemas.openxmlformats.org/presentationml/2006/main" xmlns:r="http://schemas.openxmlformats.org/officeDocument/2006/relationships">
+<p:sld xmlns:a="http://schemas.openxmlformats.org/drawingml/2006/main" xmlns:r="http://schemas.openxmlformats.org/officeDocument/2006/relationships" xmlns:p="http://schemas.openxmlformats.org/presentationml/2006/main">
   <p:cSld>
     <p:bg>
       <p:bgPr>
@@ -4208,7 +4247,14 @@
         <p:cNvGrpSpPr/>
         <p:nvPr/>
       </p:nvGrpSpPr>
-      <p:grpSpPr/>
+      <p:grpSpPr>
+        <a:xfrm>
+          <a:off x="0" y="0"/>
+          <a:ext cx="0" cy="0"/>
+          <a:chOff x="0" y="0"/>
+          <a:chExt cx="0" cy="0"/>
+        </a:xfrm>
+      </p:grpSpPr>
       <p:sp>
         <p:nvSpPr>
           <p:cNvPr id="2" name="TextBox 1"/>
@@ -4263,9 +4309,27 @@
                 <a:tableStyleId>{5C22544A-7EE6-4342-B048-85BDC9FD1C3A}</a:tableStyleId>
               </a:tblPr>
               <a:tblGrid>
-                <a:gridCol w="3718560"/>
-                <a:gridCol w="3718560"/>
-                <a:gridCol w="3718560"/>
+                <a:gridCol w="3718560">
+                  <a:extLst>
+                    <a:ext uri="{9D8B030D-6E8A-4147-A177-3AD203B41FA5}">
+                      <a16:colId xmlns:a16="http://schemas.microsoft.com/office/drawing/2014/main" val="20000"/>
+                    </a:ext>
+                  </a:extLst>
+                </a:gridCol>
+                <a:gridCol w="3718560">
+                  <a:extLst>
+                    <a:ext uri="{9D8B030D-6E8A-4147-A177-3AD203B41FA5}">
+                      <a16:colId xmlns:a16="http://schemas.microsoft.com/office/drawing/2014/main" val="20001"/>
+                    </a:ext>
+                  </a:extLst>
+                </a:gridCol>
+                <a:gridCol w="3718560">
+                  <a:extLst>
+                    <a:ext uri="{9D8B030D-6E8A-4147-A177-3AD203B41FA5}">
+                      <a16:colId xmlns:a16="http://schemas.microsoft.com/office/drawing/2014/main" val="20002"/>
+                    </a:ext>
+                  </a:extLst>
+                </a:gridCol>
               </a:tblGrid>
               <a:tr h="411480">
                 <a:tc>
@@ -4274,7 +4338,7 @@
                     <a:lstStyle/>
                     <a:p>
                       <a:pPr>
-                        <a:defRPr b="1" sz="1100">
+                        <a:defRPr sz="1100" b="1">
                           <a:solidFill>
                             <a:srgbClr val="FFFFFF"/>
                           </a:solidFill>
@@ -4297,7 +4361,7 @@
                     <a:lstStyle/>
                     <a:p>
                       <a:pPr>
-                        <a:defRPr b="1" sz="1100">
+                        <a:defRPr sz="1100" b="1">
                           <a:solidFill>
                             <a:srgbClr val="FFFFFF"/>
                           </a:solidFill>
@@ -4320,7 +4384,7 @@
                     <a:lstStyle/>
                     <a:p>
                       <a:pPr>
-                        <a:defRPr b="1" sz="1100">
+                        <a:defRPr sz="1100" b="1">
                           <a:solidFill>
                             <a:srgbClr val="FFFFFF"/>
                           </a:solidFill>
@@ -4337,6 +4401,11 @@
                     </a:solidFill>
                   </a:tcPr>
                 </a:tc>
+                <a:extLst>
+                  <a:ext uri="{0D108BD9-81ED-4DB2-BD59-A6C34878D82A}">
+                    <a16:rowId xmlns:a16="http://schemas.microsoft.com/office/drawing/2014/main" val="10000"/>
+                  </a:ext>
+                </a:extLst>
               </a:tr>
               <a:tr h="411480">
                 <a:tc>
@@ -4396,6 +4465,11 @@
                   </a:txBody>
                   <a:tcPr/>
                 </a:tc>
+                <a:extLst>
+                  <a:ext uri="{0D108BD9-81ED-4DB2-BD59-A6C34878D82A}">
+                    <a16:rowId xmlns:a16="http://schemas.microsoft.com/office/drawing/2014/main" val="10001"/>
+                  </a:ext>
+                </a:extLst>
               </a:tr>
               <a:tr h="411480">
                 <a:tc>
@@ -4467,6 +4541,11 @@
                     </a:solidFill>
                   </a:tcPr>
                 </a:tc>
+                <a:extLst>
+                  <a:ext uri="{0D108BD9-81ED-4DB2-BD59-A6C34878D82A}">
+                    <a16:rowId xmlns:a16="http://schemas.microsoft.com/office/drawing/2014/main" val="10002"/>
+                  </a:ext>
+                </a:extLst>
               </a:tr>
               <a:tr h="411480">
                 <a:tc>
@@ -4526,6 +4605,11 @@
                   </a:txBody>
                   <a:tcPr/>
                 </a:tc>
+                <a:extLst>
+                  <a:ext uri="{0D108BD9-81ED-4DB2-BD59-A6C34878D82A}">
+                    <a16:rowId xmlns:a16="http://schemas.microsoft.com/office/drawing/2014/main" val="10003"/>
+                  </a:ext>
+                </a:extLst>
               </a:tr>
               <a:tr h="411480">
                 <a:tc>
@@ -4597,6 +4681,11 @@
                     </a:solidFill>
                   </a:tcPr>
                 </a:tc>
+                <a:extLst>
+                  <a:ext uri="{0D108BD9-81ED-4DB2-BD59-A6C34878D82A}">
+                    <a16:rowId xmlns:a16="http://schemas.microsoft.com/office/drawing/2014/main" val="10004"/>
+                  </a:ext>
+                </a:extLst>
               </a:tr>
               <a:tr h="411480">
                 <a:tc>
@@ -4656,6 +4745,11 @@
                   </a:txBody>
                   <a:tcPr/>
                 </a:tc>
+                <a:extLst>
+                  <a:ext uri="{0D108BD9-81ED-4DB2-BD59-A6C34878D82A}">
+                    <a16:rowId xmlns:a16="http://schemas.microsoft.com/office/drawing/2014/main" val="10005"/>
+                  </a:ext>
+                </a:extLst>
               </a:tr>
               <a:tr h="411480">
                 <a:tc>
@@ -4727,6 +4821,11 @@
                     </a:solidFill>
                   </a:tcPr>
                 </a:tc>
+                <a:extLst>
+                  <a:ext uri="{0D108BD9-81ED-4DB2-BD59-A6C34878D82A}">
+                    <a16:rowId xmlns:a16="http://schemas.microsoft.com/office/drawing/2014/main" val="10006"/>
+                  </a:ext>
+                </a:extLst>
               </a:tr>
               <a:tr h="411480">
                 <a:tc>
@@ -4786,6 +4885,11 @@
                   </a:txBody>
                   <a:tcPr/>
                 </a:tc>
+                <a:extLst>
+                  <a:ext uri="{0D108BD9-81ED-4DB2-BD59-A6C34878D82A}">
+                    <a16:rowId xmlns:a16="http://schemas.microsoft.com/office/drawing/2014/main" val="10007"/>
+                  </a:ext>
+                </a:extLst>
               </a:tr>
             </a:tbl>
           </a:graphicData>
@@ -4835,7 +4939,7 @@
 </file>
 
 <file path=ppt/slides/slide15.xml><?xml version="1.0" encoding="utf-8"?>
-<p:sld xmlns:a="http://schemas.openxmlformats.org/drawingml/2006/main" xmlns:p="http://schemas.openxmlformats.org/presentationml/2006/main" xmlns:r="http://schemas.openxmlformats.org/officeDocument/2006/relationships">
+<p:sld xmlns:a="http://schemas.openxmlformats.org/drawingml/2006/main" xmlns:r="http://schemas.openxmlformats.org/officeDocument/2006/relationships" xmlns:p="http://schemas.openxmlformats.org/presentationml/2006/main">
   <p:cSld>
     <p:bg>
       <p:bgPr>
@@ -4851,7 +4955,14 @@
         <p:cNvGrpSpPr/>
         <p:nvPr/>
       </p:nvGrpSpPr>
-      <p:grpSpPr/>
+      <p:grpSpPr>
+        <a:xfrm>
+          <a:off x="0" y="0"/>
+          <a:ext cx="0" cy="0"/>
+          <a:chOff x="0" y="0"/>
+          <a:chExt cx="0" cy="0"/>
+        </a:xfrm>
+      </p:grpSpPr>
       <p:sp>
         <p:nvSpPr>
           <p:cNvPr id="2" name="Rectangle 1"/>
@@ -4892,6 +5003,7 @@
           <a:lstStyle/>
           <a:p>
             <a:pPr algn="ctr"/>
+            <a:endParaRPr/>
           </a:p>
         </p:txBody>
       </p:sp>
@@ -5087,7 +5199,7 @@
 </file>
 
 <file path=ppt/slides/slide16.xml><?xml version="1.0" encoding="utf-8"?>
-<p:sld xmlns:a="http://schemas.openxmlformats.org/drawingml/2006/main" xmlns:p="http://schemas.openxmlformats.org/presentationml/2006/main" xmlns:r="http://schemas.openxmlformats.org/officeDocument/2006/relationships">
+<p:sld xmlns:a="http://schemas.openxmlformats.org/drawingml/2006/main" xmlns:r="http://schemas.openxmlformats.org/officeDocument/2006/relationships" xmlns:p="http://schemas.openxmlformats.org/presentationml/2006/main">
   <p:cSld>
     <p:bg>
       <p:bgPr>
@@ -5103,7 +5215,14 @@
         <p:cNvGrpSpPr/>
         <p:nvPr/>
       </p:nvGrpSpPr>
-      <p:grpSpPr/>
+      <p:grpSpPr>
+        <a:xfrm>
+          <a:off x="0" y="0"/>
+          <a:ext cx="0" cy="0"/>
+          <a:chOff x="0" y="0"/>
+          <a:chExt cx="0" cy="0"/>
+        </a:xfrm>
+      </p:grpSpPr>
       <p:sp>
         <p:nvSpPr>
           <p:cNvPr id="2" name="Rectangle 1"/>
@@ -5144,6 +5263,7 @@
           <a:lstStyle/>
           <a:p>
             <a:pPr algn="ctr"/>
+            <a:endParaRPr/>
           </a:p>
         </p:txBody>
       </p:sp>
@@ -5339,7 +5459,7 @@
 </file>
 
 <file path=ppt/slides/slide17.xml><?xml version="1.0" encoding="utf-8"?>
-<p:sld xmlns:a="http://schemas.openxmlformats.org/drawingml/2006/main" xmlns:p="http://schemas.openxmlformats.org/presentationml/2006/main" xmlns:r="http://schemas.openxmlformats.org/officeDocument/2006/relationships">
+<p:sld xmlns:a="http://schemas.openxmlformats.org/drawingml/2006/main" xmlns:r="http://schemas.openxmlformats.org/officeDocument/2006/relationships" xmlns:p="http://schemas.openxmlformats.org/presentationml/2006/main">
   <p:cSld>
     <p:bg>
       <p:bgPr>
@@ -5355,7 +5475,14 @@
         <p:cNvGrpSpPr/>
         <p:nvPr/>
       </p:nvGrpSpPr>
-      <p:grpSpPr/>
+      <p:grpSpPr>
+        <a:xfrm>
+          <a:off x="0" y="0"/>
+          <a:ext cx="0" cy="0"/>
+          <a:chOff x="0" y="0"/>
+          <a:chExt cx="0" cy="0"/>
+        </a:xfrm>
+      </p:grpSpPr>
       <p:sp>
         <p:nvSpPr>
           <p:cNvPr id="2" name="Rectangle 1"/>
@@ -5396,6 +5523,7 @@
           <a:lstStyle/>
           <a:p>
             <a:pPr algn="ctr"/>
+            <a:endParaRPr/>
           </a:p>
         </p:txBody>
       </p:sp>
@@ -5591,7 +5719,7 @@
 </file>
 
 <file path=ppt/slides/slide18.xml><?xml version="1.0" encoding="utf-8"?>
-<p:sld xmlns:a="http://schemas.openxmlformats.org/drawingml/2006/main" xmlns:p="http://schemas.openxmlformats.org/presentationml/2006/main" xmlns:r="http://schemas.openxmlformats.org/officeDocument/2006/relationships">
+<p:sld xmlns:a="http://schemas.openxmlformats.org/drawingml/2006/main" xmlns:r="http://schemas.openxmlformats.org/officeDocument/2006/relationships" xmlns:p="http://schemas.openxmlformats.org/presentationml/2006/main">
   <p:cSld>
     <p:bg>
       <p:bgPr>
@@ -5607,7 +5735,14 @@
         <p:cNvGrpSpPr/>
         <p:nvPr/>
       </p:nvGrpSpPr>
-      <p:grpSpPr/>
+      <p:grpSpPr>
+        <a:xfrm>
+          <a:off x="0" y="0"/>
+          <a:ext cx="0" cy="0"/>
+          <a:chOff x="0" y="0"/>
+          <a:chExt cx="0" cy="0"/>
+        </a:xfrm>
+      </p:grpSpPr>
       <p:sp>
         <p:nvSpPr>
           <p:cNvPr id="2" name="TextBox 1"/>
@@ -5687,7 +5822,7 @@
 </file>
 
 <file path=ppt/slides/slide19.xml><?xml version="1.0" encoding="utf-8"?>
-<p:sld xmlns:a="http://schemas.openxmlformats.org/drawingml/2006/main" xmlns:p="http://schemas.openxmlformats.org/presentationml/2006/main" xmlns:r="http://schemas.openxmlformats.org/officeDocument/2006/relationships">
+<p:sld xmlns:a="http://schemas.openxmlformats.org/drawingml/2006/main" xmlns:r="http://schemas.openxmlformats.org/officeDocument/2006/relationships" xmlns:p="http://schemas.openxmlformats.org/presentationml/2006/main">
   <p:cSld>
     <p:bg>
       <p:bgPr>
@@ -5703,7 +5838,14 @@
         <p:cNvGrpSpPr/>
         <p:nvPr/>
       </p:nvGrpSpPr>
-      <p:grpSpPr/>
+      <p:grpSpPr>
+        <a:xfrm>
+          <a:off x="0" y="0"/>
+          <a:ext cx="0" cy="0"/>
+          <a:chOff x="0" y="0"/>
+          <a:chExt cx="0" cy="0"/>
+        </a:xfrm>
+      </p:grpSpPr>
       <p:sp>
         <p:nvSpPr>
           <p:cNvPr id="2" name="TextBox 1"/>
@@ -5758,9 +5900,27 @@
                 <a:tableStyleId>{5C22544A-7EE6-4342-B048-85BDC9FD1C3A}</a:tableStyleId>
               </a:tblPr>
               <a:tblGrid>
-                <a:gridCol w="3718560"/>
-                <a:gridCol w="3718560"/>
-                <a:gridCol w="3718560"/>
+                <a:gridCol w="3718560">
+                  <a:extLst>
+                    <a:ext uri="{9D8B030D-6E8A-4147-A177-3AD203B41FA5}">
+                      <a16:colId xmlns:a16="http://schemas.microsoft.com/office/drawing/2014/main" val="20000"/>
+                    </a:ext>
+                  </a:extLst>
+                </a:gridCol>
+                <a:gridCol w="3718560">
+                  <a:extLst>
+                    <a:ext uri="{9D8B030D-6E8A-4147-A177-3AD203B41FA5}">
+                      <a16:colId xmlns:a16="http://schemas.microsoft.com/office/drawing/2014/main" val="20001"/>
+                    </a:ext>
+                  </a:extLst>
+                </a:gridCol>
+                <a:gridCol w="3718560">
+                  <a:extLst>
+                    <a:ext uri="{9D8B030D-6E8A-4147-A177-3AD203B41FA5}">
+                      <a16:colId xmlns:a16="http://schemas.microsoft.com/office/drawing/2014/main" val="20002"/>
+                    </a:ext>
+                  </a:extLst>
+                </a:gridCol>
               </a:tblGrid>
               <a:tr h="411480">
                 <a:tc>
@@ -5769,7 +5929,7 @@
                     <a:lstStyle/>
                     <a:p>
                       <a:pPr>
-                        <a:defRPr b="1" sz="1100">
+                        <a:defRPr sz="1100" b="1">
                           <a:solidFill>
                             <a:srgbClr val="FFFFFF"/>
                           </a:solidFill>
@@ -5792,7 +5952,7 @@
                     <a:lstStyle/>
                     <a:p>
                       <a:pPr>
-                        <a:defRPr b="1" sz="1100">
+                        <a:defRPr sz="1100" b="1">
                           <a:solidFill>
                             <a:srgbClr val="FFFFFF"/>
                           </a:solidFill>
@@ -5815,7 +5975,7 @@
                     <a:lstStyle/>
                     <a:p>
                       <a:pPr>
-                        <a:defRPr b="1" sz="1100">
+                        <a:defRPr sz="1100" b="1">
                           <a:solidFill>
                             <a:srgbClr val="FFFFFF"/>
                           </a:solidFill>
@@ -5832,6 +5992,11 @@
                     </a:solidFill>
                   </a:tcPr>
                 </a:tc>
+                <a:extLst>
+                  <a:ext uri="{0D108BD9-81ED-4DB2-BD59-A6C34878D82A}">
+                    <a16:rowId xmlns:a16="http://schemas.microsoft.com/office/drawing/2014/main" val="10000"/>
+                  </a:ext>
+                </a:extLst>
               </a:tr>
               <a:tr h="411480">
                 <a:tc>
@@ -5891,6 +6056,11 @@
                   </a:txBody>
                   <a:tcPr/>
                 </a:tc>
+                <a:extLst>
+                  <a:ext uri="{0D108BD9-81ED-4DB2-BD59-A6C34878D82A}">
+                    <a16:rowId xmlns:a16="http://schemas.microsoft.com/office/drawing/2014/main" val="10001"/>
+                  </a:ext>
+                </a:extLst>
               </a:tr>
               <a:tr h="411480">
                 <a:tc>
@@ -5962,6 +6132,11 @@
                     </a:solidFill>
                   </a:tcPr>
                 </a:tc>
+                <a:extLst>
+                  <a:ext uri="{0D108BD9-81ED-4DB2-BD59-A6C34878D82A}">
+                    <a16:rowId xmlns:a16="http://schemas.microsoft.com/office/drawing/2014/main" val="10002"/>
+                  </a:ext>
+                </a:extLst>
               </a:tr>
               <a:tr h="411480">
                 <a:tc>
@@ -6021,6 +6196,11 @@
                   </a:txBody>
                   <a:tcPr/>
                 </a:tc>
+                <a:extLst>
+                  <a:ext uri="{0D108BD9-81ED-4DB2-BD59-A6C34878D82A}">
+                    <a16:rowId xmlns:a16="http://schemas.microsoft.com/office/drawing/2014/main" val="10003"/>
+                  </a:ext>
+                </a:extLst>
               </a:tr>
               <a:tr h="411480">
                 <a:tc>
@@ -6092,6 +6272,11 @@
                     </a:solidFill>
                   </a:tcPr>
                 </a:tc>
+                <a:extLst>
+                  <a:ext uri="{0D108BD9-81ED-4DB2-BD59-A6C34878D82A}">
+                    <a16:rowId xmlns:a16="http://schemas.microsoft.com/office/drawing/2014/main" val="10004"/>
+                  </a:ext>
+                </a:extLst>
               </a:tr>
               <a:tr h="411480">
                 <a:tc>
@@ -6151,6 +6336,11 @@
                   </a:txBody>
                   <a:tcPr/>
                 </a:tc>
+                <a:extLst>
+                  <a:ext uri="{0D108BD9-81ED-4DB2-BD59-A6C34878D82A}">
+                    <a16:rowId xmlns:a16="http://schemas.microsoft.com/office/drawing/2014/main" val="10005"/>
+                  </a:ext>
+                </a:extLst>
               </a:tr>
               <a:tr h="411480">
                 <a:tc>
@@ -6222,6 +6412,11 @@
                     </a:solidFill>
                   </a:tcPr>
                 </a:tc>
+                <a:extLst>
+                  <a:ext uri="{0D108BD9-81ED-4DB2-BD59-A6C34878D82A}">
+                    <a16:rowId xmlns:a16="http://schemas.microsoft.com/office/drawing/2014/main" val="10006"/>
+                  </a:ext>
+                </a:extLst>
               </a:tr>
             </a:tbl>
           </a:graphicData>
@@ -6271,7 +6466,7 @@
 </file>
 
 <file path=ppt/slides/slide2.xml><?xml version="1.0" encoding="utf-8"?>
-<p:sld xmlns:a="http://schemas.openxmlformats.org/drawingml/2006/main" xmlns:p="http://schemas.openxmlformats.org/presentationml/2006/main" xmlns:r="http://schemas.openxmlformats.org/officeDocument/2006/relationships">
+<p:sld xmlns:a="http://schemas.openxmlformats.org/drawingml/2006/main" xmlns:r="http://schemas.openxmlformats.org/officeDocument/2006/relationships" xmlns:p="http://schemas.openxmlformats.org/presentationml/2006/main">
   <p:cSld>
     <p:bg>
       <p:bgPr>
@@ -6287,7 +6482,14 @@
         <p:cNvGrpSpPr/>
         <p:nvPr/>
       </p:nvGrpSpPr>
-      <p:grpSpPr/>
+      <p:grpSpPr>
+        <a:xfrm>
+          <a:off x="0" y="0"/>
+          <a:ext cx="0" cy="0"/>
+          <a:chOff x="0" y="0"/>
+          <a:chExt cx="0" cy="0"/>
+        </a:xfrm>
+      </p:grpSpPr>
       <p:sp>
         <p:nvSpPr>
           <p:cNvPr id="2" name="Rectangle 1"/>
@@ -6328,6 +6530,7 @@
           <a:lstStyle/>
           <a:p>
             <a:pPr algn="ctr"/>
+            <a:endParaRPr/>
           </a:p>
         </p:txBody>
       </p:sp>
@@ -6538,7 +6741,7 @@
 </file>
 
 <file path=ppt/slides/slide20.xml><?xml version="1.0" encoding="utf-8"?>
-<p:sld xmlns:a="http://schemas.openxmlformats.org/drawingml/2006/main" xmlns:p="http://schemas.openxmlformats.org/presentationml/2006/main" xmlns:r="http://schemas.openxmlformats.org/officeDocument/2006/relationships">
+<p:sld xmlns:a="http://schemas.openxmlformats.org/drawingml/2006/main" xmlns:r="http://schemas.openxmlformats.org/officeDocument/2006/relationships" xmlns:p="http://schemas.openxmlformats.org/presentationml/2006/main">
   <p:cSld>
     <p:bg>
       <p:bgPr>
@@ -6554,7 +6757,14 @@
         <p:cNvGrpSpPr/>
         <p:nvPr/>
       </p:nvGrpSpPr>
-      <p:grpSpPr/>
+      <p:grpSpPr>
+        <a:xfrm>
+          <a:off x="0" y="0"/>
+          <a:ext cx="0" cy="0"/>
+          <a:chOff x="0" y="0"/>
+          <a:chExt cx="0" cy="0"/>
+        </a:xfrm>
+      </p:grpSpPr>
       <p:sp>
         <p:nvSpPr>
           <p:cNvPr id="2" name="Rectangle 1"/>
@@ -6595,6 +6805,7 @@
           <a:lstStyle/>
           <a:p>
             <a:pPr algn="ctr"/>
+            <a:endParaRPr/>
           </a:p>
         </p:txBody>
       </p:sp>
@@ -6790,7 +7001,7 @@
 </file>
 
 <file path=ppt/slides/slide21.xml><?xml version="1.0" encoding="utf-8"?>
-<p:sld xmlns:a="http://schemas.openxmlformats.org/drawingml/2006/main" xmlns:p="http://schemas.openxmlformats.org/presentationml/2006/main" xmlns:r="http://schemas.openxmlformats.org/officeDocument/2006/relationships">
+<p:sld xmlns:a="http://schemas.openxmlformats.org/drawingml/2006/main" xmlns:r="http://schemas.openxmlformats.org/officeDocument/2006/relationships" xmlns:p="http://schemas.openxmlformats.org/presentationml/2006/main">
   <p:cSld>
     <p:bg>
       <p:bgPr>
@@ -6806,7 +7017,14 @@
         <p:cNvGrpSpPr/>
         <p:nvPr/>
       </p:nvGrpSpPr>
-      <p:grpSpPr/>
+      <p:grpSpPr>
+        <a:xfrm>
+          <a:off x="0" y="0"/>
+          <a:ext cx="0" cy="0"/>
+          <a:chOff x="0" y="0"/>
+          <a:chExt cx="0" cy="0"/>
+        </a:xfrm>
+      </p:grpSpPr>
       <p:sp>
         <p:nvSpPr>
           <p:cNvPr id="2" name="Rectangle 1"/>
@@ -6847,6 +7065,7 @@
           <a:lstStyle/>
           <a:p>
             <a:pPr algn="ctr"/>
+            <a:endParaRPr/>
           </a:p>
         </p:txBody>
       </p:sp>
@@ -7077,7 +7296,7 @@
 </file>
 
 <file path=ppt/slides/slide22.xml><?xml version="1.0" encoding="utf-8"?>
-<p:sld xmlns:a="http://schemas.openxmlformats.org/drawingml/2006/main" xmlns:p="http://schemas.openxmlformats.org/presentationml/2006/main" xmlns:r="http://schemas.openxmlformats.org/officeDocument/2006/relationships">
+<p:sld xmlns:a="http://schemas.openxmlformats.org/drawingml/2006/main" xmlns:r="http://schemas.openxmlformats.org/officeDocument/2006/relationships" xmlns:p="http://schemas.openxmlformats.org/presentationml/2006/main">
   <p:cSld>
     <p:bg>
       <p:bgPr>
@@ -7093,7 +7312,14 @@
         <p:cNvGrpSpPr/>
         <p:nvPr/>
       </p:nvGrpSpPr>
-      <p:grpSpPr/>
+      <p:grpSpPr>
+        <a:xfrm>
+          <a:off x="0" y="0"/>
+          <a:ext cx="0" cy="0"/>
+          <a:chOff x="0" y="0"/>
+          <a:chExt cx="0" cy="0"/>
+        </a:xfrm>
+      </p:grpSpPr>
       <p:sp>
         <p:nvSpPr>
           <p:cNvPr id="2" name="Rectangle 1"/>
@@ -7134,6 +7360,7 @@
           <a:lstStyle/>
           <a:p>
             <a:pPr algn="ctr"/>
+            <a:endParaRPr/>
           </a:p>
         </p:txBody>
       </p:sp>
@@ -7329,7 +7556,7 @@
 </file>
 
 <file path=ppt/slides/slide23.xml><?xml version="1.0" encoding="utf-8"?>
-<p:sld xmlns:a="http://schemas.openxmlformats.org/drawingml/2006/main" xmlns:p="http://schemas.openxmlformats.org/presentationml/2006/main" xmlns:r="http://schemas.openxmlformats.org/officeDocument/2006/relationships">
+<p:sld xmlns:a="http://schemas.openxmlformats.org/drawingml/2006/main" xmlns:r="http://schemas.openxmlformats.org/officeDocument/2006/relationships" xmlns:p="http://schemas.openxmlformats.org/presentationml/2006/main">
   <p:cSld>
     <p:bg>
       <p:bgPr>
@@ -7345,7 +7572,14 @@
         <p:cNvGrpSpPr/>
         <p:nvPr/>
       </p:nvGrpSpPr>
-      <p:grpSpPr/>
+      <p:grpSpPr>
+        <a:xfrm>
+          <a:off x="0" y="0"/>
+          <a:ext cx="0" cy="0"/>
+          <a:chOff x="0" y="0"/>
+          <a:chExt cx="0" cy="0"/>
+        </a:xfrm>
+      </p:grpSpPr>
       <p:sp>
         <p:nvSpPr>
           <p:cNvPr id="2" name="Rectangle 1"/>
@@ -7386,6 +7620,7 @@
           <a:lstStyle/>
           <a:p>
             <a:pPr algn="ctr"/>
+            <a:endParaRPr/>
           </a:p>
         </p:txBody>
       </p:sp>
@@ -7503,7 +7738,7 @@
 </file>
 
 <file path=ppt/slides/slide3.xml><?xml version="1.0" encoding="utf-8"?>
-<p:sld xmlns:a="http://schemas.openxmlformats.org/drawingml/2006/main" xmlns:p="http://schemas.openxmlformats.org/presentationml/2006/main" xmlns:r="http://schemas.openxmlformats.org/officeDocument/2006/relationships">
+<p:sld xmlns:a="http://schemas.openxmlformats.org/drawingml/2006/main" xmlns:r="http://schemas.openxmlformats.org/officeDocument/2006/relationships" xmlns:p="http://schemas.openxmlformats.org/presentationml/2006/main">
   <p:cSld>
     <p:bg>
       <p:bgPr>
@@ -7519,7 +7754,14 @@
         <p:cNvGrpSpPr/>
         <p:nvPr/>
       </p:nvGrpSpPr>
-      <p:grpSpPr/>
+      <p:grpSpPr>
+        <a:xfrm>
+          <a:off x="0" y="0"/>
+          <a:ext cx="0" cy="0"/>
+          <a:chOff x="0" y="0"/>
+          <a:chExt cx="0" cy="0"/>
+        </a:xfrm>
+      </p:grpSpPr>
       <p:sp>
         <p:nvSpPr>
           <p:cNvPr id="2" name="Rectangle 1"/>
@@ -7560,6 +7802,7 @@
           <a:lstStyle/>
           <a:p>
             <a:pPr algn="ctr"/>
+            <a:endParaRPr/>
           </a:p>
         </p:txBody>
       </p:sp>
@@ -7790,7 +8033,7 @@
 </file>
 
 <file path=ppt/slides/slide4.xml><?xml version="1.0" encoding="utf-8"?>
-<p:sld xmlns:a="http://schemas.openxmlformats.org/drawingml/2006/main" xmlns:p="http://schemas.openxmlformats.org/presentationml/2006/main" xmlns:r="http://schemas.openxmlformats.org/officeDocument/2006/relationships">
+<p:sld xmlns:a="http://schemas.openxmlformats.org/drawingml/2006/main" xmlns:r="http://schemas.openxmlformats.org/officeDocument/2006/relationships" xmlns:p="http://schemas.openxmlformats.org/presentationml/2006/main">
   <p:cSld>
     <p:bg>
       <p:bgPr>
@@ -7806,7 +8049,14 @@
         <p:cNvGrpSpPr/>
         <p:nvPr/>
       </p:nvGrpSpPr>
-      <p:grpSpPr/>
+      <p:grpSpPr>
+        <a:xfrm>
+          <a:off x="0" y="0"/>
+          <a:ext cx="0" cy="0"/>
+          <a:chOff x="0" y="0"/>
+          <a:chExt cx="0" cy="0"/>
+        </a:xfrm>
+      </p:grpSpPr>
       <p:sp>
         <p:nvSpPr>
           <p:cNvPr id="2" name="TextBox 1"/>
@@ -7861,9 +8111,27 @@
                 <a:tableStyleId>{5C22544A-7EE6-4342-B048-85BDC9FD1C3A}</a:tableStyleId>
               </a:tblPr>
               <a:tblGrid>
-                <a:gridCol w="3718560"/>
-                <a:gridCol w="3718560"/>
-                <a:gridCol w="3718560"/>
+                <a:gridCol w="3718560">
+                  <a:extLst>
+                    <a:ext uri="{9D8B030D-6E8A-4147-A177-3AD203B41FA5}">
+                      <a16:colId xmlns:a16="http://schemas.microsoft.com/office/drawing/2014/main" val="20000"/>
+                    </a:ext>
+                  </a:extLst>
+                </a:gridCol>
+                <a:gridCol w="3718560">
+                  <a:extLst>
+                    <a:ext uri="{9D8B030D-6E8A-4147-A177-3AD203B41FA5}">
+                      <a16:colId xmlns:a16="http://schemas.microsoft.com/office/drawing/2014/main" val="20001"/>
+                    </a:ext>
+                  </a:extLst>
+                </a:gridCol>
+                <a:gridCol w="3718560">
+                  <a:extLst>
+                    <a:ext uri="{9D8B030D-6E8A-4147-A177-3AD203B41FA5}">
+                      <a16:colId xmlns:a16="http://schemas.microsoft.com/office/drawing/2014/main" val="20002"/>
+                    </a:ext>
+                  </a:extLst>
+                </a:gridCol>
               </a:tblGrid>
               <a:tr h="411480">
                 <a:tc>
@@ -7872,7 +8140,7 @@
                     <a:lstStyle/>
                     <a:p>
                       <a:pPr>
-                        <a:defRPr b="1" sz="1100">
+                        <a:defRPr sz="1100" b="1">
                           <a:solidFill>
                             <a:srgbClr val="FFFFFF"/>
                           </a:solidFill>
@@ -7895,7 +8163,7 @@
                     <a:lstStyle/>
                     <a:p>
                       <a:pPr>
-                        <a:defRPr b="1" sz="1100">
+                        <a:defRPr sz="1100" b="1">
                           <a:solidFill>
                             <a:srgbClr val="FFFFFF"/>
                           </a:solidFill>
@@ -7918,7 +8186,7 @@
                     <a:lstStyle/>
                     <a:p>
                       <a:pPr>
-                        <a:defRPr b="1" sz="1100">
+                        <a:defRPr sz="1100" b="1">
                           <a:solidFill>
                             <a:srgbClr val="FFFFFF"/>
                           </a:solidFill>
@@ -7935,6 +8203,11 @@
                     </a:solidFill>
                   </a:tcPr>
                 </a:tc>
+                <a:extLst>
+                  <a:ext uri="{0D108BD9-81ED-4DB2-BD59-A6C34878D82A}">
+                    <a16:rowId xmlns:a16="http://schemas.microsoft.com/office/drawing/2014/main" val="10000"/>
+                  </a:ext>
+                </a:extLst>
               </a:tr>
               <a:tr h="411480">
                 <a:tc>
@@ -7994,6 +8267,11 @@
                   </a:txBody>
                   <a:tcPr/>
                 </a:tc>
+                <a:extLst>
+                  <a:ext uri="{0D108BD9-81ED-4DB2-BD59-A6C34878D82A}">
+                    <a16:rowId xmlns:a16="http://schemas.microsoft.com/office/drawing/2014/main" val="10001"/>
+                  </a:ext>
+                </a:extLst>
               </a:tr>
               <a:tr h="411480">
                 <a:tc>
@@ -8065,6 +8343,11 @@
                     </a:solidFill>
                   </a:tcPr>
                 </a:tc>
+                <a:extLst>
+                  <a:ext uri="{0D108BD9-81ED-4DB2-BD59-A6C34878D82A}">
+                    <a16:rowId xmlns:a16="http://schemas.microsoft.com/office/drawing/2014/main" val="10002"/>
+                  </a:ext>
+                </a:extLst>
               </a:tr>
               <a:tr h="411480">
                 <a:tc>
@@ -8124,6 +8407,11 @@
                   </a:txBody>
                   <a:tcPr/>
                 </a:tc>
+                <a:extLst>
+                  <a:ext uri="{0D108BD9-81ED-4DB2-BD59-A6C34878D82A}">
+                    <a16:rowId xmlns:a16="http://schemas.microsoft.com/office/drawing/2014/main" val="10003"/>
+                  </a:ext>
+                </a:extLst>
               </a:tr>
               <a:tr h="411480">
                 <a:tc>
@@ -8195,6 +8483,11 @@
                     </a:solidFill>
                   </a:tcPr>
                 </a:tc>
+                <a:extLst>
+                  <a:ext uri="{0D108BD9-81ED-4DB2-BD59-A6C34878D82A}">
+                    <a16:rowId xmlns:a16="http://schemas.microsoft.com/office/drawing/2014/main" val="10004"/>
+                  </a:ext>
+                </a:extLst>
               </a:tr>
               <a:tr h="411480">
                 <a:tc>
@@ -8254,6 +8547,11 @@
                   </a:txBody>
                   <a:tcPr/>
                 </a:tc>
+                <a:extLst>
+                  <a:ext uri="{0D108BD9-81ED-4DB2-BD59-A6C34878D82A}">
+                    <a16:rowId xmlns:a16="http://schemas.microsoft.com/office/drawing/2014/main" val="10005"/>
+                  </a:ext>
+                </a:extLst>
               </a:tr>
               <a:tr h="411480">
                 <a:tc>
@@ -8325,6 +8623,11 @@
                     </a:solidFill>
                   </a:tcPr>
                 </a:tc>
+                <a:extLst>
+                  <a:ext uri="{0D108BD9-81ED-4DB2-BD59-A6C34878D82A}">
+                    <a16:rowId xmlns:a16="http://schemas.microsoft.com/office/drawing/2014/main" val="10006"/>
+                  </a:ext>
+                </a:extLst>
               </a:tr>
               <a:tr h="411480">
                 <a:tc>
@@ -8384,6 +8687,11 @@
                   </a:txBody>
                   <a:tcPr/>
                 </a:tc>
+                <a:extLst>
+                  <a:ext uri="{0D108BD9-81ED-4DB2-BD59-A6C34878D82A}">
+                    <a16:rowId xmlns:a16="http://schemas.microsoft.com/office/drawing/2014/main" val="10007"/>
+                  </a:ext>
+                </a:extLst>
               </a:tr>
               <a:tr h="411480">
                 <a:tc>
@@ -8455,6 +8763,11 @@
                     </a:solidFill>
                   </a:tcPr>
                 </a:tc>
+                <a:extLst>
+                  <a:ext uri="{0D108BD9-81ED-4DB2-BD59-A6C34878D82A}">
+                    <a16:rowId xmlns:a16="http://schemas.microsoft.com/office/drawing/2014/main" val="10008"/>
+                  </a:ext>
+                </a:extLst>
               </a:tr>
             </a:tbl>
           </a:graphicData>
@@ -8504,7 +8817,7 @@
 </file>
 
 <file path=ppt/slides/slide5.xml><?xml version="1.0" encoding="utf-8"?>
-<p:sld xmlns:a="http://schemas.openxmlformats.org/drawingml/2006/main" xmlns:p="http://schemas.openxmlformats.org/presentationml/2006/main" xmlns:r="http://schemas.openxmlformats.org/officeDocument/2006/relationships">
+<p:sld xmlns:a="http://schemas.openxmlformats.org/drawingml/2006/main" xmlns:r="http://schemas.openxmlformats.org/officeDocument/2006/relationships" xmlns:p="http://schemas.openxmlformats.org/presentationml/2006/main">
   <p:cSld>
     <p:bg>
       <p:bgPr>
@@ -8520,7 +8833,14 @@
         <p:cNvGrpSpPr/>
         <p:nvPr/>
       </p:nvGrpSpPr>
-      <p:grpSpPr/>
+      <p:grpSpPr>
+        <a:xfrm>
+          <a:off x="0" y="0"/>
+          <a:ext cx="0" cy="0"/>
+          <a:chOff x="0" y="0"/>
+          <a:chExt cx="0" cy="0"/>
+        </a:xfrm>
+      </p:grpSpPr>
       <p:sp>
         <p:nvSpPr>
           <p:cNvPr id="2" name="Rectangle 1"/>
@@ -8561,6 +8881,7 @@
           <a:lstStyle/>
           <a:p>
             <a:pPr algn="ctr"/>
+            <a:endParaRPr/>
           </a:p>
         </p:txBody>
       </p:sp>
@@ -8816,7 +9137,7 @@
 </file>
 
 <file path=ppt/slides/slide6.xml><?xml version="1.0" encoding="utf-8"?>
-<p:sld xmlns:a="http://schemas.openxmlformats.org/drawingml/2006/main" xmlns:p="http://schemas.openxmlformats.org/presentationml/2006/main" xmlns:r="http://schemas.openxmlformats.org/officeDocument/2006/relationships">
+<p:sld xmlns:a="http://schemas.openxmlformats.org/drawingml/2006/main" xmlns:r="http://schemas.openxmlformats.org/officeDocument/2006/relationships" xmlns:p="http://schemas.openxmlformats.org/presentationml/2006/main">
   <p:cSld>
     <p:bg>
       <p:bgPr>
@@ -8832,7 +9153,14 @@
         <p:cNvGrpSpPr/>
         <p:nvPr/>
       </p:nvGrpSpPr>
-      <p:grpSpPr/>
+      <p:grpSpPr>
+        <a:xfrm>
+          <a:off x="0" y="0"/>
+          <a:ext cx="0" cy="0"/>
+          <a:chOff x="0" y="0"/>
+          <a:chExt cx="0" cy="0"/>
+        </a:xfrm>
+      </p:grpSpPr>
       <p:sp>
         <p:nvSpPr>
           <p:cNvPr id="2" name="TextBox 1"/>
@@ -8912,7 +9240,7 @@
 </file>
 
 <file path=ppt/slides/slide7.xml><?xml version="1.0" encoding="utf-8"?>
-<p:sld xmlns:a="http://schemas.openxmlformats.org/drawingml/2006/main" xmlns:p="http://schemas.openxmlformats.org/presentationml/2006/main" xmlns:r="http://schemas.openxmlformats.org/officeDocument/2006/relationships">
+<p:sld xmlns:a="http://schemas.openxmlformats.org/drawingml/2006/main" xmlns:r="http://schemas.openxmlformats.org/officeDocument/2006/relationships" xmlns:p="http://schemas.openxmlformats.org/presentationml/2006/main">
   <p:cSld>
     <p:bg>
       <p:bgPr>
@@ -8928,7 +9256,14 @@
         <p:cNvGrpSpPr/>
         <p:nvPr/>
       </p:nvGrpSpPr>
-      <p:grpSpPr/>
+      <p:grpSpPr>
+        <a:xfrm>
+          <a:off x="0" y="0"/>
+          <a:ext cx="0" cy="0"/>
+          <a:chOff x="0" y="0"/>
+          <a:chExt cx="0" cy="0"/>
+        </a:xfrm>
+      </p:grpSpPr>
       <p:sp>
         <p:nvSpPr>
           <p:cNvPr id="2" name="Rectangle 1"/>
@@ -8969,6 +9304,7 @@
           <a:lstStyle/>
           <a:p>
             <a:pPr algn="ctr"/>
+            <a:endParaRPr/>
           </a:p>
         </p:txBody>
       </p:sp>
@@ -9196,7 +9532,7 @@
 </file>
 
 <file path=ppt/slides/slide8.xml><?xml version="1.0" encoding="utf-8"?>
-<p:sld xmlns:a="http://schemas.openxmlformats.org/drawingml/2006/main" xmlns:p="http://schemas.openxmlformats.org/presentationml/2006/main" xmlns:r="http://schemas.openxmlformats.org/officeDocument/2006/relationships">
+<p:sld xmlns:a="http://schemas.openxmlformats.org/drawingml/2006/main" xmlns:r="http://schemas.openxmlformats.org/officeDocument/2006/relationships" xmlns:p="http://schemas.openxmlformats.org/presentationml/2006/main">
   <p:cSld>
     <p:bg>
       <p:bgPr>
@@ -9212,7 +9548,14 @@
         <p:cNvGrpSpPr/>
         <p:nvPr/>
       </p:nvGrpSpPr>
-      <p:grpSpPr/>
+      <p:grpSpPr>
+        <a:xfrm>
+          <a:off x="0" y="0"/>
+          <a:ext cx="0" cy="0"/>
+          <a:chOff x="0" y="0"/>
+          <a:chExt cx="0" cy="0"/>
+        </a:xfrm>
+      </p:grpSpPr>
       <p:sp>
         <p:nvSpPr>
           <p:cNvPr id="2" name="Rectangle 1"/>
@@ -9253,6 +9596,7 @@
           <a:lstStyle/>
           <a:p>
             <a:pPr algn="ctr"/>
+            <a:endParaRPr/>
           </a:p>
         </p:txBody>
       </p:sp>
@@ -9448,7 +9792,7 @@
 </file>
 
 <file path=ppt/slides/slide9.xml><?xml version="1.0" encoding="utf-8"?>
-<p:sld xmlns:a="http://schemas.openxmlformats.org/drawingml/2006/main" xmlns:p="http://schemas.openxmlformats.org/presentationml/2006/main" xmlns:r="http://schemas.openxmlformats.org/officeDocument/2006/relationships">
+<p:sld xmlns:a="http://schemas.openxmlformats.org/drawingml/2006/main" xmlns:r="http://schemas.openxmlformats.org/officeDocument/2006/relationships" xmlns:p="http://schemas.openxmlformats.org/presentationml/2006/main">
   <p:cSld>
     <p:bg>
       <p:bgPr>
@@ -9464,7 +9808,14 @@
         <p:cNvGrpSpPr/>
         <p:nvPr/>
       </p:nvGrpSpPr>
-      <p:grpSpPr/>
+      <p:grpSpPr>
+        <a:xfrm>
+          <a:off x="0" y="0"/>
+          <a:ext cx="0" cy="0"/>
+          <a:chOff x="0" y="0"/>
+          <a:chExt cx="0" cy="0"/>
+        </a:xfrm>
+      </p:grpSpPr>
       <p:sp>
         <p:nvSpPr>
           <p:cNvPr id="2" name="Rectangle 1"/>
@@ -9505,6 +9856,7 @@
           <a:lstStyle/>
           <a:p>
             <a:pPr algn="ctr"/>
+            <a:endParaRPr/>
           </a:p>
         </p:txBody>
       </p:sp>

</xml_diff>